<commit_message>
QBR: Add date selector
</commit_message>
<xml_diff>
--- a/output/Generated_QBR.pptx
+++ b/output/Generated_QBR.pptx
@@ -263,10 +263,10 @@
                 <c:formatCode>General</c:formatCode>
                 <c:ptCount val="2"/>
                 <c:pt idx="0">
-                  <c:v>0</c:v>
+                  <c:v>287</c:v>
                 </c:pt>
                 <c:pt idx="1">
-                  <c:v>0</c:v>
+                  <c:v>204</c:v>
                 </c:pt>
               </c:numCache>
             </c:numRef>
@@ -787,16 +787,16 @@
                 <c:formatCode>General</c:formatCode>
                 <c:ptCount val="4"/>
                 <c:pt idx="0">
-                  <c:v>0</c:v>
+                  <c:v>287</c:v>
                 </c:pt>
                 <c:pt idx="1">
                   <c:v>287</c:v>
                 </c:pt>
                 <c:pt idx="2">
-                  <c:v>574</c:v>
+                  <c:v>287</c:v>
                 </c:pt>
                 <c:pt idx="3">
-                  <c:v>861</c:v>
+                  <c:v>287</c:v>
                 </c:pt>
               </c:numCache>
             </c:numRef>
@@ -998,16 +998,16 @@
                 <c:formatCode>General</c:formatCode>
                 <c:ptCount val="4"/>
                 <c:pt idx="0">
-                  <c:v>0</c:v>
+                  <c:v>204</c:v>
                 </c:pt>
                 <c:pt idx="1">
                   <c:v>204</c:v>
                 </c:pt>
                 <c:pt idx="2">
-                  <c:v>447</c:v>
+                  <c:v>204</c:v>
                 </c:pt>
                 <c:pt idx="3">
-                  <c:v>735</c:v>
+                  <c:v>204</c:v>
                 </c:pt>
               </c:numCache>
             </c:numRef>
@@ -14720,7 +14720,7 @@
                           </a:solidFill>
                           <a:latin typeface="Calibri"/>
                         </a:rPr>
-                        <a:t>0</a:t>
+                        <a:t>287</a:t>
                       </a:r>
                     </a:p>
                   </a:txBody>
@@ -14766,7 +14766,7 @@
                           </a:solidFill>
                           <a:latin typeface="Calibri"/>
                         </a:rPr>
-                        <a:t>287</a:t>
+                        <a:t>0</a:t>
                       </a:r>
                     </a:p>
                   </a:txBody>
@@ -14842,7 +14842,7 @@
                           </a:solidFill>
                           <a:latin typeface="Calibri"/>
                         </a:rPr>
-                        <a:t>0</a:t>
+                        <a:t>204</a:t>
                       </a:r>
                     </a:p>
                   </a:txBody>
@@ -14888,7 +14888,7 @@
                           </a:solidFill>
                           <a:latin typeface="Calibri"/>
                         </a:rPr>
-                        <a:t>204</a:t>
+                        <a:t>0</a:t>
                       </a:r>
                     </a:p>
                   </a:txBody>
@@ -14964,7 +14964,7 @@
                           </a:solidFill>
                           <a:latin typeface="Calibri"/>
                         </a:rPr>
-                        <a:t>0</a:t>
+                        <a:t>10</a:t>
                       </a:r>
                     </a:p>
                   </a:txBody>
@@ -15010,7 +15010,7 @@
                           </a:solidFill>
                           <a:latin typeface="Calibri"/>
                         </a:rPr>
-                        <a:t>10</a:t>
+                        <a:t>0</a:t>
                       </a:r>
                     </a:p>
                   </a:txBody>
@@ -15086,7 +15086,7 @@
                           </a:solidFill>
                           <a:latin typeface="Calibri"/>
                         </a:rPr>
-                        <a:t>0</a:t>
+                        <a:t>20</a:t>
                       </a:r>
                     </a:p>
                   </a:txBody>
@@ -15132,7 +15132,7 @@
                           </a:solidFill>
                           <a:latin typeface="Calibri"/>
                         </a:rPr>
-                        <a:t>20</a:t>
+                        <a:t>0</a:t>
                       </a:r>
                     </a:p>
                   </a:txBody>
@@ -15208,7 +15208,7 @@
                           </a:solidFill>
                           <a:latin typeface="Calibri"/>
                         </a:rPr>
-                        <a:t>0</a:t>
+                        <a:t>6</a:t>
                       </a:r>
                     </a:p>
                   </a:txBody>
@@ -15254,7 +15254,7 @@
                           </a:solidFill>
                           <a:latin typeface="Calibri"/>
                         </a:rPr>
-                        <a:t>6</a:t>
+                        <a:t>0</a:t>
                       </a:r>
                     </a:p>
                   </a:txBody>
@@ -19676,7 +19676,7 @@
                           </a:solidFill>
                           <a:latin typeface="Calibri"/>
                         </a:rPr>
-                        <a:t>0</a:t>
+                        <a:t>287</a:t>
                       </a:r>
                     </a:p>
                   </a:txBody>
@@ -19729,7 +19729,7 @@
                           </a:solidFill>
                           <a:latin typeface="Calibri"/>
                         </a:rPr>
-                        <a:t>0</a:t>
+                        <a:t>204</a:t>
                       </a:r>
                     </a:p>
                   </a:txBody>
@@ -19782,7 +19782,7 @@
                           </a:solidFill>
                           <a:latin typeface="Calibri"/>
                         </a:rPr>
-                        <a:t>0</a:t>
+                        <a:t>10</a:t>
                       </a:r>
                     </a:p>
                   </a:txBody>
@@ -19835,7 +19835,7 @@
                           </a:solidFill>
                           <a:latin typeface="Calibri"/>
                         </a:rPr>
-                        <a:t>0</a:t>
+                        <a:t>20</a:t>
                       </a:r>
                     </a:p>
                   </a:txBody>
@@ -19888,7 +19888,7 @@
                           </a:solidFill>
                           <a:latin typeface="Calibri"/>
                         </a:rPr>
-                        <a:t>0</a:t>
+                        <a:t>6</a:t>
                       </a:r>
                     </a:p>
                   </a:txBody>
@@ -23567,7 +23567,7 @@
             <a:p>
               <a:pPr algn="ctr"/>
               <a:r>
-                <a:t>0</a:t>
+                <a:t>287</a:t>
               </a:r>
               <a:endParaRPr lang="en-US">
                 <a:latin typeface="Montserrat" panose="00000500000000000000" pitchFamily="2" charset="0"/>
@@ -23735,7 +23735,7 @@
             <a:p>
               <a:pPr algn="ctr"/>
               <a:r>
-                <a:t>0</a:t>
+                <a:t>204</a:t>
               </a:r>
               <a:endParaRPr lang="en-US">
                 <a:latin typeface="Montserrat" panose="00000500000000000000" pitchFamily="2" charset="0"/>
@@ -23903,7 +23903,7 @@
             <a:p>
               <a:pPr algn="ctr"/>
               <a:r>
-                <a:t>0</a:t>
+                <a:t>10</a:t>
               </a:r>
               <a:endParaRPr lang="en-US">
                 <a:latin typeface="Montserrat" panose="00000500000000000000" pitchFamily="2" charset="0"/>
@@ -24071,7 +24071,7 @@
             <a:p>
               <a:pPr algn="ctr"/>
               <a:r>
-                <a:t>0</a:t>
+                <a:t>20</a:t>
               </a:r>
               <a:endParaRPr lang="en-US">
                 <a:latin typeface="Montserrat" panose="00000500000000000000" pitchFamily="2" charset="0"/>
@@ -24239,7 +24239,7 @@
             <a:p>
               <a:pPr algn="ctr"/>
               <a:r>
-                <a:t>0</a:t>
+                <a:t>6</a:t>
               </a:r>
               <a:endParaRPr lang="en-US">
                 <a:latin typeface="Montserrat" panose="00000500000000000000" pitchFamily="2" charset="0"/>

</xml_diff>